<commit_message>
fix(slides): update official Vietnamese topic title and correct group members name and student IDs
</commit_message>
<xml_diff>
--- a/BaoCao/Slide_BaoCao_DeTai4_Nhom9.pptx
+++ b/BaoCao/Slide_BaoCao_DeTai4_Nhom9.pptx
@@ -3150,8 +3150,8 @@
         </p:nvSpPr>
         <p:spPr>
           <a:xfrm>
-            <a:off x="731520" y="548640"/>
-            <a:ext cx="10728655" cy="475488"/>
+            <a:off x="731520" y="502920"/>
+            <a:ext cx="10728655" cy="457200"/>
           </a:xfrm>
           <a:prstGeom prst="roundRect">
             <a:avLst/>
@@ -3184,7 +3184,7 @@
           <a:lstStyle/>
           <a:p>
             <a:pPr algn="ctr">
-              <a:defRPr sz="1250" b="1">
+              <a:defRPr sz="1200" b="1">
                 <a:solidFill>
                   <a:srgbClr val="BAE6FD"/>
                 </a:solidFill>
@@ -3205,8 +3205,8 @@
         </p:nvSpPr>
         <p:spPr>
           <a:xfrm>
-            <a:off x="731520" y="1234440"/>
-            <a:ext cx="10728655" cy="2011680"/>
+            <a:off x="731520" y="1143000"/>
+            <a:ext cx="10728655" cy="2194560"/>
           </a:xfrm>
           <a:prstGeom prst="rect">
             <a:avLst/>
@@ -3221,9 +3221,9 @@
           <a:p>
             <a:pPr>
               <a:spcAft>
-                <a:spcPts val="600"/>
+                <a:spcPts val="400"/>
               </a:spcAft>
-              <a:defRPr sz="1500" b="1">
+              <a:defRPr sz="1400" b="1">
                 <a:solidFill>
                   <a:srgbClr val="38BDF8"/>
                 </a:solidFill>
@@ -3231,15 +3231,18 @@
               </a:defRPr>
             </a:pPr>
             <a:r>
-              <a:t>BÁO CÁO THỰC TẬP &amp; ĐỒ ÁN MÔN HỌC</a:t>
-            </a:r>
-          </a:p>
-          <a:p>
-            <a:pPr>
+              <a:t>BÁO CÁO BÀI TẬP LỚN • HỌC PHẦN: KIỂM THỬ PHẦN MỀM</a:t>
+            </a:r>
+          </a:p>
+          <a:p>
+            <a:pPr>
+              <a:lnSpc>
+                <a:spcPct val="115000"/>
+              </a:lnSpc>
               <a:spcAft>
                 <a:spcPts val="600"/>
               </a:spcAft>
-              <a:defRPr sz="3200" b="1">
+              <a:defRPr sz="2600" b="1">
                 <a:solidFill>
                   <a:srgbClr val="FFFFFF"/>
                 </a:solidFill>
@@ -3247,12 +3250,16 @@
               </a:defRPr>
             </a:pPr>
             <a:r>
-              <a:t>ĐỀ TÀI 4: KIỂM THỬ PHẦN MỀM PETCARE PRO</a:t>
-            </a:r>
-          </a:p>
-          <a:p>
-            <a:pPr>
-              <a:defRPr sz="1400">
+              <a:t>ĐỀ TÀI 4: XÂY DỰNG VÀ KIỂM THỬ HỆ THỐNG QUẢN LÝ</a:t>
+            </a:r>
+            <a:br/>
+            <a:r>
+              <a:t>DỊCH VỤ CHĂM SÓC THÚ CƯNG</a:t>
+            </a:r>
+          </a:p>
+          <a:p>
+            <a:pPr>
+              <a:defRPr sz="1300">
                 <a:solidFill>
                   <a:srgbClr val="CBD5E1"/>
                 </a:solidFill>
@@ -3260,7 +3267,7 @@
               </a:defRPr>
             </a:pPr>
             <a:r>
-              <a:t>Hệ thống Quản lý Dịch vụ Thú cưng Toàn diện • 240 Test Cases (Unit - Integration - System Automation)</a:t>
+              <a:t>Giải pháp Quản lý Cửa hàng &amp; Dịch vụ Toàn diện • 240 Ca kiểm thử (Đơn vị - Tích hợp - Hệ thống Tự động hóa)</a:t>
             </a:r>
           </a:p>
         </p:txBody>
@@ -3273,7 +3280,7 @@
         </p:nvSpPr>
         <p:spPr>
           <a:xfrm>
-            <a:off x="731520" y="3520440"/>
+            <a:off x="731520" y="3566160"/>
             <a:ext cx="3429000" cy="2057400"/>
           </a:xfrm>
           <a:prstGeom prst="roundRect">
@@ -3303,43 +3310,59 @@
           </a:fontRef>
         </p:style>
         <p:txBody>
-          <a:bodyPr rtlCol="0" anchor="ctr" wrap="square" lIns="228600" rIns="228600"/>
+          <a:bodyPr rtlCol="0" anchor="ctr" wrap="square" lIns="201168" rIns="201168"/>
           <a:lstStyle/>
           <a:p>
             <a:pPr algn="ctr">
+              <a:spcAft>
+                <a:spcPts val="200"/>
+              </a:spcAft>
+              <a:defRPr sz="1150" b="1">
+                <a:solidFill>
+                  <a:srgbClr val="38BDF8"/>
+                </a:solidFill>
+                <a:latin typeface="Segoe UI"/>
+              </a:defRPr>
+            </a:pPr>
+            <a:r>
+              <a:t>★ TRƯỞNG NHÓM</a:t>
+            </a:r>
+          </a:p>
+          <a:p>
+            <a:pPr>
               <a:spcAft>
                 <a:spcPts val="400"/>
               </a:spcAft>
-              <a:defRPr sz="1150" b="1">
-                <a:solidFill>
-                  <a:srgbClr val="38BDF8"/>
-                </a:solidFill>
-                <a:latin typeface="Segoe UI"/>
-              </a:defRPr>
-            </a:pPr>
-            <a:r>
-              <a:t>★ TRƯỞNG NHÓM - MSV: 20221398</a:t>
+              <a:defRPr sz="1750" b="1">
+                <a:solidFill>
+                  <a:srgbClr val="FFFFFF"/>
+                </a:solidFill>
+                <a:latin typeface="Segoe UI"/>
+              </a:defRPr>
+            </a:pPr>
+            <a:r>
+              <a:t>Đặng Văn Mạnh</a:t>
             </a:r>
           </a:p>
           <a:p>
             <a:pPr>
               <a:spcAft>
-                <a:spcPts val="600"/>
+                <a:spcPts val="400"/>
               </a:spcAft>
-              <a:defRPr sz="1800" b="1">
-                <a:solidFill>
-                  <a:srgbClr val="FFFFFF"/>
-                </a:solidFill>
-                <a:latin typeface="Segoe UI"/>
-              </a:defRPr>
-            </a:pPr>
-            <a:r>
-              <a:t>Vũ Xuân Mạnh</a:t>
-            </a:r>
-          </a:p>
-          <a:p>
-            <a:pPr>
-              <a:defRPr sz="1200">
+              <a:defRPr sz="1100" b="1">
+                <a:solidFill>
+                  <a:srgbClr val="BAE6FD"/>
+                </a:solidFill>
+                <a:latin typeface="Segoe UI"/>
+              </a:defRPr>
+            </a:pPr>
+            <a:r>
+              <a:t>MSV: 20232652 • Lớp: DCCNTT 14.C.3</a:t>
+            </a:r>
+          </a:p>
+          <a:p>
+            <a:pPr>
+              <a:defRPr sz="1150">
                 <a:solidFill>
                   <a:srgbClr val="CBD5E1"/>
                 </a:solidFill>
@@ -3347,7 +3370,7 @@
               </a:defRPr>
             </a:pPr>
             <a:r>
-              <a:t>Phụ trách Unit Test &amp; Test Automation Selenium 4</a:t>
+              <a:t>Phụ trách Kiểm thử Đơn vị (Unit Test) &amp; Kiểm thử Tự động</a:t>
             </a:r>
           </a:p>
         </p:txBody>
@@ -3360,7 +3383,7 @@
         </p:nvSpPr>
         <p:spPr>
           <a:xfrm>
-            <a:off x="4379976" y="3520440"/>
+            <a:off x="4379976" y="3566160"/>
             <a:ext cx="3429000" cy="2057400"/>
           </a:xfrm>
           <a:prstGeom prst="roundRect">
@@ -3390,43 +3413,59 @@
           </a:fontRef>
         </p:style>
         <p:txBody>
-          <a:bodyPr rtlCol="0" anchor="ctr" wrap="square" lIns="228600" rIns="228600"/>
+          <a:bodyPr rtlCol="0" anchor="ctr" wrap="square" lIns="201168" rIns="201168"/>
           <a:lstStyle/>
           <a:p>
             <a:pPr algn="ctr">
+              <a:spcAft>
+                <a:spcPts val="200"/>
+              </a:spcAft>
+              <a:defRPr sz="1150" b="1">
+                <a:solidFill>
+                  <a:srgbClr val="38BDF8"/>
+                </a:solidFill>
+                <a:latin typeface="Segoe UI"/>
+              </a:defRPr>
+            </a:pPr>
+            <a:r>
+              <a:t>★ THÀNH VIÊN</a:t>
+            </a:r>
+          </a:p>
+          <a:p>
+            <a:pPr>
               <a:spcAft>
                 <a:spcPts val="400"/>
               </a:spcAft>
-              <a:defRPr sz="1150" b="1">
-                <a:solidFill>
-                  <a:srgbClr val="38BDF8"/>
-                </a:solidFill>
-                <a:latin typeface="Segoe UI"/>
-              </a:defRPr>
-            </a:pPr>
-            <a:r>
-              <a:t>★ THÀNH VIÊN - MSV: 20220678</a:t>
+              <a:defRPr sz="1750" b="1">
+                <a:solidFill>
+                  <a:srgbClr val="FFFFFF"/>
+                </a:solidFill>
+                <a:latin typeface="Segoe UI"/>
+              </a:defRPr>
+            </a:pPr>
+            <a:r>
+              <a:t>Trần Ngọc Sơn</a:t>
             </a:r>
           </a:p>
           <a:p>
             <a:pPr>
               <a:spcAft>
-                <a:spcPts val="600"/>
+                <a:spcPts val="400"/>
               </a:spcAft>
-              <a:defRPr sz="1800" b="1">
-                <a:solidFill>
-                  <a:srgbClr val="FFFFFF"/>
-                </a:solidFill>
-                <a:latin typeface="Segoe UI"/>
-              </a:defRPr>
-            </a:pPr>
-            <a:r>
-              <a:t>Nguyễn Thế Sơn</a:t>
-            </a:r>
-          </a:p>
-          <a:p>
-            <a:pPr>
-              <a:defRPr sz="1200">
+              <a:defRPr sz="1100" b="1">
+                <a:solidFill>
+                  <a:srgbClr val="BAE6FD"/>
+                </a:solidFill>
+                <a:latin typeface="Segoe UI"/>
+              </a:defRPr>
+            </a:pPr>
+            <a:r>
+              <a:t>MSV: 20232472 • Lớp: DCCNTT 14.C.3</a:t>
+            </a:r>
+          </a:p>
+          <a:p>
+            <a:pPr>
+              <a:defRPr sz="1150">
                 <a:solidFill>
                   <a:srgbClr val="CBD5E1"/>
                 </a:solidFill>
@@ -3434,7 +3473,7 @@
               </a:defRPr>
             </a:pPr>
             <a:r>
-              <a:t>Phụ trách Integration Test &amp; Soạn thảo Báo cáo</a:t>
+              <a:t>Phụ trách Kiểm thử Tích hợp (Integration Test) &amp; Báo cáo</a:t>
             </a:r>
           </a:p>
         </p:txBody>
@@ -3447,7 +3486,7 @@
         </p:nvSpPr>
         <p:spPr>
           <a:xfrm>
-            <a:off x="8028432" y="3520440"/>
+            <a:off x="8028432" y="3566160"/>
             <a:ext cx="3429000" cy="2057400"/>
           </a:xfrm>
           <a:prstGeom prst="roundRect">
@@ -3477,43 +3516,59 @@
           </a:fontRef>
         </p:style>
         <p:txBody>
-          <a:bodyPr rtlCol="0" anchor="ctr" wrap="square" lIns="228600" rIns="228600"/>
+          <a:bodyPr rtlCol="0" anchor="ctr" wrap="square" lIns="201168" rIns="201168"/>
           <a:lstStyle/>
           <a:p>
             <a:pPr algn="ctr">
+              <a:spcAft>
+                <a:spcPts val="200"/>
+              </a:spcAft>
+              <a:defRPr sz="1150" b="1">
+                <a:solidFill>
+                  <a:srgbClr val="38BDF8"/>
+                </a:solidFill>
+                <a:latin typeface="Segoe UI"/>
+              </a:defRPr>
+            </a:pPr>
+            <a:r>
+              <a:t>★ THÀNH VIÊN</a:t>
+            </a:r>
+          </a:p>
+          <a:p>
+            <a:pPr>
               <a:spcAft>
                 <a:spcPts val="400"/>
               </a:spcAft>
-              <a:defRPr sz="1150" b="1">
-                <a:solidFill>
-                  <a:srgbClr val="38BDF8"/>
-                </a:solidFill>
-                <a:latin typeface="Segoe UI"/>
-              </a:defRPr>
-            </a:pPr>
-            <a:r>
-              <a:t>★ THÀNH VIÊN - MSV: 20220123</a:t>
+              <a:defRPr sz="1750" b="1">
+                <a:solidFill>
+                  <a:srgbClr val="FFFFFF"/>
+                </a:solidFill>
+                <a:latin typeface="Segoe UI"/>
+              </a:defRPr>
+            </a:pPr>
+            <a:r>
+              <a:t>Ngô Hoàng Anh</a:t>
             </a:r>
           </a:p>
           <a:p>
             <a:pPr>
               <a:spcAft>
-                <a:spcPts val="600"/>
+                <a:spcPts val="400"/>
               </a:spcAft>
-              <a:defRPr sz="1800" b="1">
-                <a:solidFill>
-                  <a:srgbClr val="FFFFFF"/>
-                </a:solidFill>
-                <a:latin typeface="Segoe UI"/>
-              </a:defRPr>
-            </a:pPr>
-            <a:r>
-              <a:t>Dương Hoàng Anh</a:t>
-            </a:r>
-          </a:p>
-          <a:p>
-            <a:pPr>
-              <a:defRPr sz="1200">
+              <a:defRPr sz="1100" b="1">
+                <a:solidFill>
+                  <a:srgbClr val="BAE6FD"/>
+                </a:solidFill>
+                <a:latin typeface="Segoe UI"/>
+              </a:defRPr>
+            </a:pPr>
+            <a:r>
+              <a:t>MSV: 20232558 • Lớp: DCCNTT 14.C.3</a:t>
+            </a:r>
+          </a:p>
+          <a:p>
+            <a:pPr>
+              <a:defRPr sz="1150">
                 <a:solidFill>
                   <a:srgbClr val="CBD5E1"/>
                 </a:solidFill>
@@ -3521,7 +3576,7 @@
               </a:defRPr>
             </a:pPr>
             <a:r>
-              <a:t>Phụ trách System Test &amp; UI/UX Responsive</a:t>
+              <a:t>Phụ trách Kiểm thử Hệ thống (System Test) &amp; Giao diện UI/UX</a:t>
             </a:r>
           </a:p>
         </p:txBody>
@@ -3549,7 +3604,7 @@
           <a:lstStyle/>
           <a:p>
             <a:pPr algn="ctr">
-              <a:defRPr sz="1200">
+              <a:defRPr sz="1150">
                 <a:solidFill>
                   <a:srgbClr val="94A3B8"/>
                 </a:solidFill>
@@ -3557,7 +3612,7 @@
               </a:defRPr>
             </a:pPr>
             <a:r>
-              <a:t>Giảng viên hướng dẫn: ThS. Hoàng Thị Phương Lan • Nhóm 9 • Lớp: CNTT-K13 • Hà Nội 2026</a:t>
+              <a:t>Giảng viên hướng dẫn: ThS. Hoàng Thị Phương Lan • Nhóm 9 • Lớp tín chỉ: Kiểm thử phần mềm-1-1-26(N04) • Hà Nội 2026</a:t>
             </a:r>
           </a:p>
         </p:txBody>
@@ -3682,7 +3737,7 @@
           <a:lstStyle/>
           <a:p>
             <a:pPr>
-              <a:defRPr sz="2400" b="1">
+              <a:defRPr sz="2300" b="1">
                 <a:solidFill>
                   <a:srgbClr val="0F172A"/>
                 </a:solidFill>
@@ -3690,7 +3745,7 @@
               </a:defRPr>
             </a:pPr>
             <a:r>
-              <a:t>Quy Trình Quản Lý &amp; Xử Lý Lỗi (Defect Lifecycle)</a:t>
+              <a:t>Quy Trình Quản Lý &amp; Xử Lý Lỗi (Vòng đời lỗi)</a:t>
             </a:r>
           </a:p>
         </p:txBody>
@@ -3788,7 +3843,7 @@
               </a:defRPr>
             </a:pPr>
             <a:r>
-              <a:t>🔄 VÒNG ĐỜI XỬ LÝ BUG (BUG LIFECYCLE)</a:t>
+              <a:t>🔄 VÒNG ĐỜI XỬ LÝ LỖI (DEFECT LIFECYCLE)</a:t>
             </a:r>
           </a:p>
           <a:p>
@@ -3843,7 +3898,7 @@
                 </a:solidFill>
                 <a:latin typeface="Segoe UI"/>
               </a:rPr>
-              <a:t>• 1. New (Phát hiện lỗi): </a:t>
+              <a:t>• 1. Mới (Phát hiện lỗi): </a:t>
             </a:r>
             <a:r>
               <a:rPr sz="1200">
@@ -3871,7 +3926,7 @@
                 </a:solidFill>
                 <a:latin typeface="Segoe UI"/>
               </a:rPr>
-              <a:t>• 2. Assigned (Phân công): </a:t>
+              <a:t>• 2. Phân công (Assigned): </a:t>
             </a:r>
             <a:r>
               <a:rPr sz="1200">
@@ -3880,7 +3935,7 @@
                 </a:solidFill>
                 <a:latin typeface="Segoe UI"/>
               </a:rPr>
-              <a:t>Gán lỗi cho Developer phụ trách module tương ứng, xác định độ nghiêm trọng (Severity: High/Medium/Low).</a:t>
+              <a:t>Gán lỗi cho Developer phụ trách module tương ứng, xác định độ nghiêm trọng (Nghiêm trọng / Cao / Trung bình).</a:t>
             </a:r>
           </a:p>
           <a:p>
@@ -3899,7 +3954,7 @@
                 </a:solidFill>
                 <a:latin typeface="Segoe UI"/>
               </a:rPr>
-              <a:t>• 3. Fixed (Đã sửa): </a:t>
+              <a:t>• 3. Đã sửa (Fixed): </a:t>
             </a:r>
             <a:r>
               <a:rPr sz="1200">
@@ -3927,7 +3982,7 @@
                 </a:solidFill>
                 <a:latin typeface="Segoe UI"/>
               </a:rPr>
-              <a:t>• 4. Retest (Kiểm thử lại): </a:t>
+              <a:t>• 4. Kiểm thử lại (Retest): </a:t>
             </a:r>
             <a:r>
               <a:rPr sz="1200">
@@ -3955,7 +4010,7 @@
                 </a:solidFill>
                 <a:latin typeface="Segoe UI"/>
               </a:rPr>
-              <a:t>• 5. Closed (Đóng lỗi): </a:t>
+              <a:t>• 5. Đóng lỗi (Closed): </a:t>
             </a:r>
             <a:r>
               <a:rPr sz="1200">
@@ -4207,7 +4262,7 @@
                 </a:solidFill>
                 <a:latin typeface="Segoe UI"/>
               </a:rPr>
-              <a:t>4/4 lỗi đã sửa xong 100% (Ví dụ: Chặn trừ kho âm, sửa tính sai tổng tiền voucher, lỗi mất session).</a:t>
+              <a:t>4/4 lỗi đã sửa xong 100% (Ví dụ: Chặn trừ kho âm, sửa tính sai tổng tiền voucher, lỗi mất phiên đăng nhập).</a:t>
             </a:r>
           </a:p>
           <a:p>
@@ -4263,7 +4318,7 @@
                 </a:solidFill>
                 <a:latin typeface="Segoe UI"/>
               </a:rPr>
-              <a:t>0 Lỗi Critical, 0 Lỗi High. Hệ thống vận hành cực kỳ mượt mà, sẵn sàng triển khai thực tế.</a:t>
+              <a:t>0 Lỗi Nghiêm trọng, 0 Lỗi Cao. Hệ thống vận hành cực kỳ mượt mà, sẵn sàng triển khai thực tế.</a:t>
             </a:r>
           </a:p>
         </p:txBody>
@@ -4441,7 +4496,7 @@
           <a:lstStyle/>
           <a:p>
             <a:pPr>
-              <a:defRPr sz="2400" b="1">
+              <a:defRPr sz="2300" b="1">
                 <a:solidFill>
                   <a:srgbClr val="0F172A"/>
                 </a:solidFill>
@@ -4520,7 +4575,7 @@
               </a:defRPr>
             </a:pPr>
             <a:r>
-              <a:t>TỔNG TEST CASES</a:t>
+              <a:t>TỔNG CA KIỂM THỬ</a:t>
             </a:r>
           </a:p>
           <a:p>
@@ -4533,7 +4588,7 @@
               </a:defRPr>
             </a:pPr>
             <a:r>
-              <a:t>Unit + Integration + System</a:t>
+              <a:t>Đơn vị + Tích hợp + Hệ thống</a:t>
             </a:r>
           </a:p>
         </p:txBody>
@@ -4604,7 +4659,7 @@
               </a:defRPr>
             </a:pPr>
             <a:r>
-              <a:t>TỶ LỆ PASS</a:t>
+              <a:t>TỶ LỆ ĐẠT (PASS)</a:t>
             </a:r>
           </a:p>
           <a:p>
@@ -4701,7 +4756,7 @@
               </a:defRPr>
             </a:pPr>
             <a:r>
-              <a:t>Toàn diện từ Code đến UI/UX</a:t>
+              <a:t>Toàn diện từ Mã nguồn đến UI/UX</a:t>
             </a:r>
           </a:p>
         </p:txBody>
@@ -4759,7 +4814,7 @@
               </a:defRPr>
             </a:pPr>
             <a:r>
-              <a:t>0 BUG</a:t>
+              <a:t>0 LỖI</a:t>
             </a:r>
           </a:p>
           <a:p>
@@ -4896,7 +4951,7 @@
               </a:defRPr>
             </a:pPr>
             <a:r>
-              <a:t>Hệ thống PetCare Pro đáp ứng trọn vẹn yêu cầu chất lượng</a:t>
+              <a:t>Hệ thống đáp ứng trọn vẹn mọi yêu cầu chất lượng</a:t>
             </a:r>
           </a:p>
         </p:txBody>
@@ -4947,7 +5002,7 @@
                 </a:solidFill>
                 <a:latin typeface="Segoe UI"/>
               </a:rPr>
-              <a:t>Hệ thống hoạt động ổn định, chính xác 100% trong mọi kịch bản bán hàng, quản lý kho, đặt lịch Spa và quản lý thú cưng.</a:t>
+              <a:t>Hệ thống hoạt động ổn định, chính xác 100% trong mọi kịch bản bán hàng, quản lý kho, đặt lịch Spa và quản lý hồ sơ thú cưng.</a:t>
             </a:r>
           </a:p>
           <a:p>
@@ -4975,7 +5030,7 @@
                 </a:solidFill>
                 <a:latin typeface="Segoe UI"/>
               </a:rPr>
-              <a:t>Phân quyền chặt chẽ giữa Admin/Staff/Customer, chống kho âm, tính toán chiết khấu voucher chuẩn xác tuyệt đối.</a:t>
+              <a:t>Phân quyền chặt chẽ giữa Quản trị/Nhân viên/Khách hàng, chống kho âm, tính toán chiết khấu voucher chuẩn xác tuyệt đối.</a:t>
             </a:r>
           </a:p>
           <a:p>
@@ -5003,7 +5058,7 @@
                 </a:solidFill>
                 <a:latin typeface="Segoe UI"/>
               </a:rPr>
-              <a:t>Mã nguồn được cấu trúc module rõ ràng theo kiến trúc Clean Architecture, dễ dàng tích hợp thêm cổng thanh toán online hoặc Mobile App.</a:t>
+              <a:t>Mã nguồn được cấu trúc module rõ ràng, dễ dàng tích hợp thêm cổng thanh toán trực tuyến hoặc Ứng dụng Di động.</a:t>
             </a:r>
           </a:p>
           <a:p>
@@ -5031,7 +5086,7 @@
                 </a:solidFill>
                 <a:latin typeface="Segoe UI"/>
               </a:rPr>
-              <a:t>Hệ thống đáp ứng hoàn hảo nhu cầu vận hành thực tế của các chuỗi cửa hàng chăm sóc thú cưng hiện nay.</a:t>
+              <a:t>Hệ thống đáp ứng hoàn hảo nhu cầu vận hành thực tế của các cửa hàng và chuỗi dịch vụ chăm sóc thú cưng hiện nay.</a:t>
             </a:r>
           </a:p>
         </p:txBody>
@@ -5256,7 +5311,7 @@
           </a:p>
           <a:p>
             <a:pPr algn="ctr">
-              <a:defRPr sz="1350" b="1">
+              <a:defRPr sz="1300" b="1">
                 <a:solidFill>
                   <a:srgbClr val="CBD5E1"/>
                 </a:solidFill>
@@ -5264,7 +5319,7 @@
               </a:defRPr>
             </a:pPr>
             <a:r>
-              <a:t>Nhóm 9: Vũ Xuân Mạnh • Nguyễn Thế Sơn • Dương Hoàng Anh (Đại học Công Nghệ Đông Á)</a:t>
+              <a:t>Nhóm 9: Đặng Văn Mạnh (20232652) • Trần Ngọc Sơn (20232472) • Ngô Hoàng Anh (20232558) • Lớp: DCCNTT 14.C.3</a:t>
             </a:r>
           </a:p>
         </p:txBody>
@@ -5389,7 +5444,7 @@
           <a:lstStyle/>
           <a:p>
             <a:pPr>
-              <a:defRPr sz="2400" b="1">
+              <a:defRPr sz="2300" b="1">
                 <a:solidFill>
                   <a:srgbClr val="0F172A"/>
                 </a:solidFill>
@@ -5397,7 +5452,7 @@
               </a:defRPr>
             </a:pPr>
             <a:r>
-              <a:t>Hệ Thống Quản Lý Cửa Hàng Thú Cưng PetCare Pro</a:t>
+              <a:t>Hệ Thống Quản Lý Dịch Vụ Chăm Sóc Thú Cưng</a:t>
             </a:r>
           </a:p>
         </p:txBody>
@@ -5508,7 +5563,7 @@
               </a:defRPr>
             </a:pPr>
             <a:r>
-              <a:t>Vấn đề ngành chăm sóc thú cưng</a:t>
+              <a:t>Vấn đề quản lý dịch vụ thú cưng</a:t>
             </a:r>
           </a:p>
         </p:txBody>
@@ -5559,7 +5614,7 @@
                 </a:solidFill>
                 <a:latin typeface="Segoe UI"/>
               </a:rPr>
-              <a:t>Dễ thất thoát doanh thu, nhầm lẫn lịch hẹn Spa/Grooming của khách hàng.</a:t>
+              <a:t>Dễ thất thoát doanh thu, nhầm lẫn lịch hẹn Spa/Làm đẹp của khách hàng.</a:t>
             </a:r>
           </a:p>
           <a:p>
@@ -5615,7 +5670,7 @@
                 </a:solidFill>
                 <a:latin typeface="Segoe UI"/>
               </a:rPr>
-              <a:t>Cần phần mềm All-in-One quản lý thông tin thú cưng, hồ sơ y tế, tiêm phòng và lịch sử dịch vụ.</a:t>
+              <a:t>Cần phần mềm quản lý thông tin thú cưng, hồ sơ khám bệnh, tiêm phòng và lịch sử dịch vụ.</a:t>
             </a:r>
           </a:p>
           <a:p>
@@ -5643,7 +5698,7 @@
                 </a:solidFill>
                 <a:latin typeface="Segoe UI"/>
               </a:rPr>
-              <a:t>Tối ưu hóa quy trình bán hàng POS, đặt lịch nhanh chóng, nâng cao sự hài lòng của khách hàng.</a:t>
+              <a:t>Tối ưu hóa quy trình bán hàng POS, đặt lịch nhanh chóng, tăng trải nghiệm khách hàng.</a:t>
             </a:r>
           </a:p>
         </p:txBody>
@@ -5696,7 +5751,7 @@
               </a:defRPr>
             </a:pPr>
             <a:r>
-              <a:t>★ Chuyển đổi số toàn diện cho Pet Shop</a:t>
+              <a:t>★ Chuyển đổi số toàn diện cho Cửa hàng</a:t>
             </a:r>
           </a:p>
         </p:txBody>
@@ -5858,7 +5913,7 @@
                 </a:solidFill>
                 <a:latin typeface="Segoe UI"/>
               </a:rPr>
-              <a:t>Hồ sơ chi tiết, phân 4 hạng VIP (Bronze, Silver, Gold, Platinum).</a:t>
+              <a:t>Hồ sơ chi tiết, phân 4 hạng thành viên (Đồng, Bạc, Vàng, Bạch Kim).</a:t>
             </a:r>
           </a:p>
           <a:p>
@@ -5877,7 +5932,7 @@
                 </a:solidFill>
                 <a:latin typeface="Segoe UI"/>
               </a:rPr>
-              <a:t>• Đặt lịch Spa &amp; Khám bệnh: </a:t>
+              <a:t>• Đặt lịch Spa &amp; Dịch vụ: </a:t>
             </a:r>
             <a:r>
               <a:rPr sz="1200">
@@ -5886,7 +5941,7 @@
                 </a:solidFill>
                 <a:latin typeface="Segoe UI"/>
               </a:rPr>
-              <a:t>Quy trình 7 bước, phân công thợ lành nghề, lịch biểu thông minh.</a:t>
+              <a:t>Quy trình 7 bước, phân công kỹ thuật viên, lịch biểu thông minh.</a:t>
             </a:r>
           </a:p>
           <a:p>
@@ -5914,7 +5969,7 @@
                 </a:solidFill>
                 <a:latin typeface="Segoe UI"/>
               </a:rPr>
-              <a:t>Bán hàng nhanh, quét mã, cảnh báo hết hàng, chặn kho âm.</a:t>
+              <a:t>Bán hàng nhanh, quét mã, cảnh báo hết hàng, chặn trừ kho âm.</a:t>
             </a:r>
           </a:p>
           <a:p>
@@ -6134,7 +6189,7 @@
               </a:defRPr>
             </a:pPr>
             <a:r>
-              <a:t>Fullstack Clean Architecture</a:t>
+              <a:t>Kiến trúc hệ thống chuẩn mực</a:t>
             </a:r>
           </a:p>
         </p:txBody>
@@ -6176,7 +6231,7 @@
                 </a:solidFill>
                 <a:latin typeface="Segoe UI"/>
               </a:rPr>
-              <a:t>• Frontend SPA: </a:t>
+              <a:t>• Giao diện Frontend: </a:t>
             </a:r>
             <a:r>
               <a:rPr sz="1200">
@@ -6204,7 +6259,7 @@
                 </a:solidFill>
                 <a:latin typeface="Segoe UI"/>
               </a:rPr>
-              <a:t>• Backend Service: </a:t>
+              <a:t>• Dịch vụ Backend: </a:t>
             </a:r>
             <a:r>
               <a:rPr sz="1200">
@@ -6232,7 +6287,7 @@
                 </a:solidFill>
                 <a:latin typeface="Segoe UI"/>
               </a:rPr>
-              <a:t>• Database &amp; State: </a:t>
+              <a:t>• Cơ sở dữ liệu: </a:t>
             </a:r>
             <a:r>
               <a:rPr sz="1200">
@@ -6350,7 +6405,7 @@
               </a:defRPr>
             </a:pPr>
             <a:r>
-              <a:t>⚡ Tương thích Đa nền tảng &amp; Mobile</a:t>
+              <a:t>⚡ Tương thích Đa nền tảng &amp; Di động</a:t>
             </a:r>
           </a:p>
         </p:txBody>
@@ -6475,7 +6530,7 @@
           <a:lstStyle/>
           <a:p>
             <a:pPr>
-              <a:defRPr sz="2400" b="1">
+              <a:defRPr sz="2300" b="1">
                 <a:solidFill>
                   <a:srgbClr val="0F172A"/>
                 </a:solidFill>
@@ -6673,7 +6728,7 @@
                 </a:solidFill>
                 <a:latin typeface="Segoe UI"/>
               </a:rPr>
-              <a:t>Đảm bảo tồn kho không âm khi xuất hàng đồng thời; lịch hẹn Spa không bị trùng giờ hoặc phân nhầm kỹ thuật viên.</a:t>
+              <a:t>Đảm bảo tồn kho không âm khi xuất hàng đồng thời; lịch hẹn Spa không bị trùng giờ hoặc phân nhầm nhân viên phụ trách.</a:t>
             </a:r>
           </a:p>
           <a:p>
@@ -6935,7 +6990,7 @@
                 </a:solidFill>
                 <a:latin typeface="Segoe UI"/>
               </a:rPr>
-              <a:t>• Unit Test (70 Test Cases): </a:t>
+              <a:t>• Unit Test (70 Ca kiểm thử): </a:t>
             </a:r>
             <a:r>
               <a:rPr sz="1300">
@@ -6944,7 +6999,7 @@
                 </a:solidFill>
                 <a:latin typeface="Segoe UI"/>
               </a:rPr>
-              <a:t>Kiểm tra từng hàm, logic tính toán, validate Regex email/SĐT, xử lý chuỗi và quản trị State của từng Store riêng biệt.</a:t>
+              <a:t>Kiểm tra từng hàm, logic tính toán, validate định dạng email/SĐT, xử lý chuỗi và quản trị State dữ liệu.</a:t>
             </a:r>
           </a:p>
           <a:p>
@@ -6963,7 +7018,7 @@
                 </a:solidFill>
                 <a:latin typeface="Segoe UI"/>
               </a:rPr>
-              <a:t>• Integration Test (70 Test Cases): </a:t>
+              <a:t>• Integration Test (70 Ca kiểm thử): </a:t>
             </a:r>
             <a:r>
               <a:rPr sz="1300">
@@ -6972,7 +7027,7 @@
                 </a:solidFill>
                 <a:latin typeface="Segoe UI"/>
               </a:rPr>
-              <a:t>Kiểm tra tích hợp liên module: POS trừ kho, Lịch hẹn đẩy vào Calendar, Router Guard chặn quyền, Client gọi API.</a:t>
+              <a:t>Kiểm tra tích hợp liên module: POS trừ kho, Lịch hẹn đẩy vào Lịch biểu, Phân quyền chặn truy cập, Client gọi API.</a:t>
             </a:r>
           </a:p>
           <a:p>
@@ -6991,7 +7046,7 @@
                 </a:solidFill>
                 <a:latin typeface="Segoe UI"/>
               </a:rPr>
-              <a:t>• System Test (100 Test Cases): </a:t>
+              <a:t>• System Test (100 Ca kiểm thử): </a:t>
             </a:r>
             <a:r>
               <a:rPr sz="1300">
@@ -7081,7 +7136,7 @@
               </a:defRPr>
             </a:pPr>
             <a:r>
-              <a:t>✔ Hoàn thành 100% (240/240 Test Cases Pass)</a:t>
+              <a:t>✔ Hoàn thành 100% (240/240 Ca kiểm thử Pass)</a:t>
             </a:r>
           </a:p>
         </p:txBody>
@@ -7206,7 +7261,7 @@
           <a:lstStyle/>
           <a:p>
             <a:pPr>
-              <a:defRPr sz="2400" b="1">
+              <a:defRPr sz="2300" b="1">
                 <a:solidFill>
                   <a:srgbClr val="0F172A"/>
                 </a:solidFill>
@@ -7367,7 +7422,7 @@
                 </a:solidFill>
                 <a:latin typeface="Segoe UI"/>
               </a:rPr>
-              <a:t>• Khảo sát SRS: </a:t>
+              <a:t>• Khảo sát tài liệu: </a:t>
             </a:r>
             <a:r>
               <a:rPr sz="1200">
@@ -7376,7 +7431,7 @@
                 </a:solidFill>
                 <a:latin typeface="Segoe UI"/>
               </a:rPr>
-              <a:t>Nghiên cứu tài liệu yêu cầu nghiệp vụ PetCare.</a:t>
+              <a:t>Nghiên cứu yêu cầu nghiệp vụ hệ thống quản lý thú cưng.</a:t>
             </a:r>
           </a:p>
           <a:p>
@@ -7750,7 +7805,7 @@
                 </a:solidFill>
                 <a:latin typeface="Segoe UI"/>
               </a:rPr>
-              <a:t>• Review chéo: </a:t>
+              <a:t>• Thẩm định chéo: </a:t>
             </a:r>
             <a:r>
               <a:rPr sz="1200">
@@ -7965,7 +8020,7 @@
                 </a:solidFill>
                 <a:latin typeface="Segoe UI"/>
               </a:rPr>
-              <a:t>• Thực thi Manual: </a:t>
+              <a:t>• Thực thi Thủ công: </a:t>
             </a:r>
             <a:r>
               <a:rPr sz="1200">
@@ -8030,7 +8085,7 @@
                 </a:solidFill>
                 <a:latin typeface="Segoe UI"/>
               </a:rPr>
-              <a:t>Log lỗi chi tiết, gắn mức độ Severity và đính kèm ảnh chụp.</a:t>
+              <a:t>Log lỗi chi tiết, gắn mức độ nghiêm trọng và đính kèm ảnh chụp.</a:t>
             </a:r>
           </a:p>
           <a:p>
@@ -8049,7 +8104,7 @@
                 </a:solidFill>
                 <a:latin typeface="Segoe UI"/>
               </a:rPr>
-              <a:t>• File chạy .bat: </a:t>
+              <a:t>• Kịch bản chạy .bat: </a:t>
             </a:r>
             <a:r>
               <a:rPr sz="1200">
@@ -8058,7 +8113,7 @@
                 </a:solidFill>
                 <a:latin typeface="Segoe UI"/>
               </a:rPr>
-              <a:t>Tạo các kịch bản chạy tự động 1 click tiện lợi.</a:t>
+              <a:t>Tạo các file chạy tự động 1 click tiện lợi.</a:t>
             </a:r>
           </a:p>
         </p:txBody>
@@ -8264,7 +8319,7 @@
                 </a:solidFill>
                 <a:latin typeface="Segoe UI"/>
               </a:rPr>
-              <a:t>• Retest &amp; Verify: </a:t>
+              <a:t>• Kiểm thử lại (Retest): </a:t>
             </a:r>
             <a:r>
               <a:rPr sz="1200">
@@ -8273,7 +8328,7 @@
                 </a:solidFill>
                 <a:latin typeface="Segoe UI"/>
               </a:rPr>
-              <a:t>Kiểm tra lại sau khi Developer sửa lỗi thành công.</a:t>
+              <a:t>Kiểm tra lại sau khi lỗi đã được sửa thành công.</a:t>
             </a:r>
           </a:p>
           <a:p>
@@ -8535,7 +8590,7 @@
           <a:lstStyle/>
           <a:p>
             <a:pPr>
-              <a:defRPr sz="2400" b="1">
+              <a:defRPr sz="2300" b="1">
                 <a:solidFill>
                   <a:srgbClr val="0F172A"/>
                 </a:solidFill>
@@ -8641,7 +8696,7 @@
               </a:defRPr>
             </a:pPr>
             <a:r>
-              <a:t>VŨ XUÂN MẠNH</a:t>
+              <a:t>ĐẶNG VĂN MẠNH</a:t>
             </a:r>
           </a:p>
           <a:p>
@@ -8654,7 +8709,7 @@
               </a:defRPr>
             </a:pPr>
             <a:r>
-              <a:t>TRƯỞNG NHÓM (33.3% ĐÓNG GÓP)</a:t>
+              <a:t>TRƯỞNG NHÓM (MSV: 20232652)</a:t>
             </a:r>
           </a:p>
         </p:txBody>
@@ -8705,7 +8760,7 @@
                 </a:solidFill>
                 <a:latin typeface="Segoe UI"/>
               </a:rPr>
-              <a:t>Chịu trách nhiệm Cấp độ 1 - Unit Test (70 Test Cases).</a:t>
+              <a:t>Chịu trách nhiệm Cấp độ 1 - Kiểm thử Đơn vị (70 Unit Test Cases).</a:t>
             </a:r>
           </a:p>
           <a:p>
@@ -8733,7 +8788,7 @@
                 </a:solidFill>
                 <a:latin typeface="Segoe UI"/>
               </a:rPr>
-              <a:t>Viết test case logic Auth, Customer, Pet, Product, Service, POS &amp; Orders.</a:t>
+              <a:t>Viết test case logic Xác thực, Khách hàng, Thú cưng, Sản phẩm, Dịch vụ, Bán hàng POS.</a:t>
             </a:r>
           </a:p>
           <a:p>
@@ -8940,7 +8995,7 @@
               </a:defRPr>
             </a:pPr>
             <a:r>
-              <a:t>NGUYỄN THẾ SƠN</a:t>
+              <a:t>TRẦN NGỌC SƠN</a:t>
             </a:r>
           </a:p>
           <a:p>
@@ -8953,7 +9008,7 @@
               </a:defRPr>
             </a:pPr>
             <a:r>
-              <a:t>THÀNH VIÊN (33.3% ĐÓNG GÓP)</a:t>
+              <a:t>THÀNH VIÊN (MSV: 20232472)</a:t>
             </a:r>
           </a:p>
         </p:txBody>
@@ -9004,7 +9059,7 @@
                 </a:solidFill>
                 <a:latin typeface="Segoe UI"/>
               </a:rPr>
-              <a:t>Chịu trách nhiệm Cấp độ 2 - Integration Test (70 Test Cases).</a:t>
+              <a:t>Chịu trách nhiệm Cấp độ 2 - Kiểm thử Tích hợp (70 Integration Test Cases).</a:t>
             </a:r>
           </a:p>
           <a:p>
@@ -9239,7 +9294,7 @@
               </a:defRPr>
             </a:pPr>
             <a:r>
-              <a:t>DƯƠNG HOÀNG ANH</a:t>
+              <a:t>NGÔ HOÀNG ANH</a:t>
             </a:r>
           </a:p>
           <a:p>
@@ -9252,7 +9307,7 @@
               </a:defRPr>
             </a:pPr>
             <a:r>
-              <a:t>THÀNH VIÊN (33.3% ĐÓNG GÓP)</a:t>
+              <a:t>THÀNH VIÊN (MSV: 20232558)</a:t>
             </a:r>
           </a:p>
         </p:txBody>
@@ -9303,7 +9358,7 @@
                 </a:solidFill>
                 <a:latin typeface="Segoe UI"/>
               </a:rPr>
-              <a:t>Chịu trách nhiệm Cấp độ 3 - System Test (100 Test Cases).</a:t>
+              <a:t>Chịu trách nhiệm Cấp độ 3 - Kiểm thử Hệ thống (100 System Test Cases).</a:t>
             </a:r>
           </a:p>
           <a:p>
@@ -9565,7 +9620,7 @@
           <a:lstStyle/>
           <a:p>
             <a:pPr>
-              <a:defRPr sz="2400" b="1">
+              <a:defRPr sz="2300" b="1">
                 <a:solidFill>
                   <a:srgbClr val="0F172A"/>
                 </a:solidFill>
@@ -9573,7 +9628,7 @@
               </a:defRPr>
             </a:pPr>
             <a:r>
-              <a:t>Kiểm Thử Đơn Vị - Unit Test (70 Test Cases)</a:t>
+              <a:t>Kiểm Thử Đơn Vị - Unit Test (70 Ca kiểm thử)</a:t>
             </a:r>
           </a:p>
         </p:txBody>
@@ -9726,7 +9781,7 @@
                 </a:solidFill>
                 <a:latin typeface="Segoe UI"/>
               </a:rPr>
-              <a:t>• Auth Service (10 TC): </a:t>
+              <a:t>• Xác thực Auth (10 TC): </a:t>
             </a:r>
             <a:r>
               <a:rPr sz="1150">
@@ -9735,7 +9790,7 @@
                 </a:solidFill>
                 <a:latin typeface="Segoe UI"/>
               </a:rPr>
-              <a:t>Đăng nhập, đăng xuất, phân quyền Role, regex email, session null safety.</a:t>
+              <a:t>Đăng nhập, đăng xuất, phân quyền Role, regex email, kiểm tra phiên làm việc.</a:t>
             </a:r>
           </a:p>
           <a:p>
@@ -9754,7 +9809,7 @@
                 </a:solidFill>
                 <a:latin typeface="Segoe UI"/>
               </a:rPr>
-              <a:t>• Customer Store (12 TC): </a:t>
+              <a:t>• Quản lý Khách hàng (12 TC): </a:t>
             </a:r>
             <a:r>
               <a:rPr sz="1150">
@@ -9763,7 +9818,7 @@
                 </a:solidFill>
                 <a:latin typeface="Segoe UI"/>
               </a:rPr>
-              <a:t>Thêm/sửa/xóa khách, sinh mã KH-xxxx, fallback email, 4 hạng VIP.</a:t>
+              <a:t>Thêm/sửa/xóa khách, sinh mã KH-xxxx, fallback email, 4 hạng thành viên.</a:t>
             </a:r>
           </a:p>
           <a:p>
@@ -9782,7 +9837,7 @@
                 </a:solidFill>
                 <a:latin typeface="Segoe UI"/>
               </a:rPr>
-              <a:t>• Pet Store (8 TC): </a:t>
+              <a:t>• Quản lý Thú cưng (8 TC): </a:t>
             </a:r>
             <a:r>
               <a:rPr sz="1150">
@@ -9810,7 +9865,7 @@
                 </a:solidFill>
                 <a:latin typeface="Segoe UI"/>
               </a:rPr>
-              <a:t>• Product Store (10 TC): </a:t>
+              <a:t>• Quản lý Sản phẩm (10 TC): </a:t>
             </a:r>
             <a:r>
               <a:rPr sz="1150">
@@ -9819,7 +9874,7 @@
                 </a:solidFill>
                 <a:latin typeface="Segoe UI"/>
               </a:rPr>
-              <a:t>Sinh mã SKU-PET, cập nhật tồn kho, chặn trừ kho âm (Math.max).</a:t>
+              <a:t>Sinh mã SKU, cập nhật tồn kho, chặn trừ kho âm (Math.max).</a:t>
             </a:r>
           </a:p>
           <a:p>
@@ -9838,7 +9893,7 @@
                 </a:solidFill>
                 <a:latin typeface="Segoe UI"/>
               </a:rPr>
-              <a:t>• Service Store (6 TC): </a:t>
+              <a:t>• Quản lý Dịch vụ (6 TC): </a:t>
             </a:r>
             <a:r>
               <a:rPr sz="1150">
@@ -9847,7 +9902,7 @@
                 </a:solidFill>
                 <a:latin typeface="Segoe UI"/>
               </a:rPr>
-              <a:t>Thêm/sửa giá dịch vụ, bật/tắt active, xóa an toàn, phân loại.</a:t>
+              <a:t>Thêm/sửa giá dịch vụ, bật/tắt active, xóa an toàn, phân loại danh mục.</a:t>
             </a:r>
           </a:p>
           <a:p>
@@ -9866,7 +9921,7 @@
                 </a:solidFill>
                 <a:latin typeface="Segoe UI"/>
               </a:rPr>
-              <a:t>• POS &amp; Orders (16 TC): </a:t>
+              <a:t>• Bán hàng POS &amp; Đơn (16 TC): </a:t>
             </a:r>
             <a:r>
               <a:rPr sz="1150">
@@ -9894,7 +9949,7 @@
                 </a:solidFill>
                 <a:latin typeface="Segoe UI"/>
               </a:rPr>
-              <a:t>• Appointment Store (8 TC): </a:t>
+              <a:t>• Đặt lịch hẹn (8 TC): </a:t>
             </a:r>
             <a:r>
               <a:rPr sz="1150">
@@ -9903,7 +9958,7 @@
                 </a:solidFill>
                 <a:latin typeface="Segoe UI"/>
               </a:rPr>
-              <a:t>Tạo lịch hẹn, sinh mã LH-xxxx, phân công thợ Spa, dời giờ.</a:t>
+              <a:t>Tạo lịch hẹn, sinh mã LH-xxxx, phân công nhân viên Spa, dời giờ.</a:t>
             </a:r>
           </a:p>
         </p:txBody>
@@ -9956,7 +10011,7 @@
               </a:defRPr>
             </a:pPr>
             <a:r>
-              <a:t>✔ 70/70 Test Cases Pass (Tỷ lệ 100%)</a:t>
+              <a:t>✔ 70/70 Ca kiểm thử Pass (Tỷ lệ 100%)</a:t>
             </a:r>
           </a:p>
         </p:txBody>
@@ -10289,7 +10344,7 @@
               </a:defRPr>
             </a:pPr>
             <a:r>
-              <a:t>✔ UT_AUTH_003: Chặn vai trò Customer vào Admin</a:t>
+              <a:t>✔ UT_AUTH_003: Chặn vai trò Khách hàng vào Quản trị</a:t>
             </a:r>
           </a:p>
           <a:p>
@@ -10309,7 +10364,7 @@
             </a:r>
             <a:br/>
             <a:r>
-              <a:t>• Xử lý: Router Guard kiểm tra quyền Staff/Admin</a:t>
+              <a:t>• Xử lý: Router Guard kiểm tra quyền Nhân viên/Quản trị</a:t>
             </a:r>
             <a:br/>
             <a:r>
@@ -10491,7 +10546,7 @@
           <a:lstStyle/>
           <a:p>
             <a:pPr>
-              <a:defRPr sz="2400" b="1">
+              <a:defRPr sz="2300" b="1">
                 <a:solidFill>
                   <a:srgbClr val="0F172A"/>
                 </a:solidFill>
@@ -10499,7 +10554,7 @@
               </a:defRPr>
             </a:pPr>
             <a:r>
-              <a:t>Kiểm Thử Tích Hợp - Integration Test (70 Test Cases)</a:t>
+              <a:t>Kiểm Thử Tích Hợp - Integration Test (70 Ca kiểm thử)</a:t>
             </a:r>
           </a:p>
         </p:txBody>
@@ -10597,7 +10652,7 @@
               </a:defRPr>
             </a:pPr>
             <a:r>
-              <a:t>TÍCH HỢP STATE &amp; UI</a:t>
+              <a:t>TÍCH HỢP STATE &amp; GIAO DIỆN</a:t>
             </a:r>
           </a:p>
           <a:p>
@@ -10610,7 +10665,7 @@
               </a:defRPr>
             </a:pPr>
             <a:r>
-              <a:t>Quy mô: 32 Test Cases</a:t>
+              <a:t>Quy mô: 32 Ca kiểm thử</a:t>
             </a:r>
           </a:p>
         </p:txBody>
@@ -10652,7 +10707,7 @@
                 </a:solidFill>
                 <a:latin typeface="Segoe UI"/>
               </a:rPr>
-              <a:t>• Auth ↔ Router Guard: </a:t>
+              <a:t>• Xác thực ↔ Điều hướng Menu: </a:t>
             </a:r>
             <a:r>
               <a:rPr sz="1300">
@@ -10680,7 +10735,7 @@
                 </a:solidFill>
                 <a:latin typeface="Segoe UI"/>
               </a:rPr>
-              <a:t>• Form Đặt lịch ↔ Calendar: </a:t>
+              <a:t>• Form Đặt lịch ↔ Lịch biểu: </a:t>
             </a:r>
             <a:r>
               <a:rPr sz="1300">
@@ -10689,7 +10744,7 @@
                 </a:solidFill>
                 <a:latin typeface="Segoe UI"/>
               </a:rPr>
-              <a:t>Quy trình 7 bước đặt lịch Spa đồng bộ ngay lên lịch làm việc của thợ.</a:t>
+              <a:t>Quy trình 7 bước đặt lịch Spa đồng bộ ngay lên lịch làm việc nhân viên.</a:t>
             </a:r>
           </a:p>
           <a:p>
@@ -10736,7 +10791,7 @@
                 </a:solidFill>
                 <a:latin typeface="Segoe UI"/>
               </a:rPr>
-              <a:t>• Đổi trạng thái ↔ Badge UI: </a:t>
+              <a:t>• Đổi trạng thái ↔ Đổi màu Badge: </a:t>
             </a:r>
             <a:r>
               <a:rPr sz="1300">
@@ -10745,7 +10800,7 @@
                 </a:solidFill>
                 <a:latin typeface="Segoe UI"/>
               </a:rPr>
-              <a:t>Thay đổi trạng thái đơn hàng/lịch hẹn tự động đổi màu Badge tức thì.</a:t>
+              <a:t>Thay đổi trạng thái đơn hàng/lịch hẹn tự động cập nhật màu sắc tức thì.</a:t>
             </a:r>
           </a:p>
         </p:txBody>
@@ -10798,7 +10853,7 @@
               </a:defRPr>
             </a:pPr>
             <a:r>
-              <a:t>✔ 32/32 Passed (100%)</a:t>
+              <a:t>✔ 32/32 Ca kiểm thử Đạt (100%)</a:t>
             </a:r>
           </a:p>
         </p:txBody>
@@ -10909,7 +10964,7 @@
               </a:defRPr>
             </a:pPr>
             <a:r>
-              <a:t>Quy mô: 22 Test Cases</a:t>
+              <a:t>Quy mô: 22 Ca kiểm thử</a:t>
             </a:r>
           </a:p>
         </p:txBody>
@@ -11097,7 +11152,7 @@
               </a:defRPr>
             </a:pPr>
             <a:r>
-              <a:t>✔ 22/22 Passed (100%)</a:t>
+              <a:t>✔ 22/22 Ca kiểm thử Đạt (100%)</a:t>
             </a:r>
           </a:p>
         </p:txBody>
@@ -11208,7 +11263,7 @@
               </a:defRPr>
             </a:pPr>
             <a:r>
-              <a:t>Quy mô: 16 Test Cases</a:t>
+              <a:t>Quy mô: 16 Ca kiểm thử</a:t>
             </a:r>
           </a:p>
         </p:txBody>
@@ -11259,7 +11314,7 @@
                 </a:solidFill>
                 <a:latin typeface="Segoe UI"/>
               </a:rPr>
-              <a:t>Lấy danh sách sản phẩm trả về mã HTTP 200 OK kèm payload JSON.</a:t>
+              <a:t>Lấy danh sách sản phẩm trả về mã HTTP 200 OK kèm dữ liệu JSON.</a:t>
             </a:r>
           </a:p>
           <a:p>
@@ -11287,7 +11342,7 @@
                 </a:solidFill>
                 <a:latin typeface="Segoe UI"/>
               </a:rPr>
-              <a:t>Tạo đơn hàng đẩy lên server trả về HTTP 201 Created chuẩn xác.</a:t>
+              <a:t>Tạo đơn hàng gửi lên máy chủ trả về HTTP 201 Created chuẩn xác.</a:t>
             </a:r>
           </a:p>
           <a:p>
@@ -11315,7 +11370,7 @@
                 </a:solidFill>
                 <a:latin typeface="Segoe UI"/>
               </a:rPr>
-              <a:t>Đồng bộ số liệu doanh thu và KPI tổng quan theo thời gian thực.</a:t>
+              <a:t>Đồng bộ số liệu doanh thu và chỉ số thống kê theo thời gian thực.</a:t>
             </a:r>
           </a:p>
           <a:p>
@@ -11396,7 +11451,7 @@
               </a:defRPr>
             </a:pPr>
             <a:r>
-              <a:t>✔ 16/16 Passed (100%)</a:t>
+              <a:t>✔ 16/16 Ca kiểm thử Đạt (100%)</a:t>
             </a:r>
           </a:p>
         </p:txBody>
@@ -11521,7 +11576,7 @@
           <a:lstStyle/>
           <a:p>
             <a:pPr>
-              <a:defRPr sz="2400" b="1">
+              <a:defRPr sz="2300" b="1">
                 <a:solidFill>
                   <a:srgbClr val="0F172A"/>
                 </a:solidFill>
@@ -11529,7 +11584,7 @@
               </a:defRPr>
             </a:pPr>
             <a:r>
-              <a:t>Kiểm Thử Hệ Thống - System Test (100 Test Cases)</a:t>
+              <a:t>Kiểm Thử Hệ Thống - System Test (100 Ca kiểm thử)</a:t>
             </a:r>
           </a:p>
         </p:txBody>
@@ -11640,7 +11695,7 @@
               </a:defRPr>
             </a:pPr>
             <a:r>
-              <a:t>Kịch bản vận hành thực tế End-to-End (E2E)</a:t>
+              <a:t>Kịch bản vận hành thực tế Toàn diện (E2E)</a:t>
             </a:r>
           </a:p>
         </p:txBody>
@@ -11682,7 +11737,7 @@
                 </a:solidFill>
                 <a:latin typeface="Segoe UI"/>
               </a:rPr>
-              <a:t>• Luồng E2E Đặt lịch Spa (15 TC): </a:t>
+              <a:t>• Luồng Đặt lịch Dịch vụ Spa (15 TC): </a:t>
             </a:r>
             <a:r>
               <a:rPr sz="1300">
@@ -11691,7 +11746,7 @@
                 </a:solidFill>
                 <a:latin typeface="Segoe UI"/>
               </a:rPr>
-              <a:t>Khách vào web -&gt; Đặt lịch 7 bước -&gt; Phân công thợ -&gt; Thực hiện dịch vụ -&gt; Thanh toán POS -&gt; Lưu hồ sơ.</a:t>
+              <a:t>Khách vào web -&gt; Đặt lịch 7 bước -&gt; Phân công nhân viên -&gt; Thực hiện dịch vụ -&gt; Thanh toán POS -&gt; Lưu hồ sơ.</a:t>
             </a:r>
           </a:p>
           <a:p>
@@ -11710,7 +11765,7 @@
                 </a:solidFill>
                 <a:latin typeface="Segoe UI"/>
               </a:rPr>
-              <a:t>• Luồng E2E Bán hàng POS (15 TC): </a:t>
+              <a:t>• Luồng Bán hàng POS &amp; Kho (15 TC): </a:t>
             </a:r>
             <a:r>
               <a:rPr sz="1300">
@@ -11719,7 +11774,7 @@
                 </a:solidFill>
                 <a:latin typeface="Segoe UI"/>
               </a:rPr>
-              <a:t>Quét mã SP -&gt; Thêm giỏ hàng -&gt; Chọn khách VIP -&gt; Áp voucher -&gt; Thanh toán đa phương thức -&gt; In hóa đơn.</a:t>
+              <a:t>Quét mã SP -&gt; Thêm giỏ hàng -&gt; Chọn khách thành viên -&gt; Áp voucher -&gt; Thanh toán đa phương thức -&gt; In hóa đơn.</a:t>
             </a:r>
           </a:p>
           <a:p>
@@ -11747,7 +11802,7 @@
                 </a:solidFill>
                 <a:latin typeface="Segoe UI"/>
               </a:rPr>
-              <a:t>Thêm mới chủ và pet -&gt; Tìm kiếm theo SĐT -&gt; Nâng hạng VIP -&gt; Lịch sử khám chữa bệnh.</a:t>
+              <a:t>Thêm mới chủ và pet -&gt; Tìm kiếm theo SĐT -&gt; Xếp hạng thành viên -&gt; Lịch sử khám chữa bệnh.</a:t>
             </a:r>
           </a:p>
           <a:p>
@@ -11766,7 +11821,7 @@
                 </a:solidFill>
                 <a:latin typeface="Segoe UI"/>
               </a:rPr>
-              <a:t>• Luồng Quản lý Dịch vụ &amp; Báo cáo (15 TC): </a:t>
+              <a:t>• Luồng Quản lý Bảng giá &amp; Báo cáo (15 TC): </a:t>
             </a:r>
             <a:r>
               <a:rPr sz="1300">
@@ -11775,7 +11830,7 @@
                 </a:solidFill>
                 <a:latin typeface="Segoe UI"/>
               </a:rPr>
-              <a:t>Cấu hình bảng giá -&gt; Kiểm tra doanh thu ngày/tháng -&gt; Biểu đồ Chart.js -&gt; Xuất báo cáo Excel.</a:t>
+              <a:t>Cấu hình giá dịch vụ -&gt; Kiểm tra doanh thu ngày/tháng -&gt; Biểu đồ trực quan -&gt; Xuất báo cáo.</a:t>
             </a:r>
           </a:p>
         </p:txBody>
@@ -11981,7 +12036,7 @@
                 </a:solidFill>
                 <a:latin typeface="Segoe UI"/>
               </a:rPr>
-              <a:t>• Responsive &amp; Đa thiết bị (12 TC): </a:t>
+              <a:t>• Đa thiết bị Responsive (12 TC): </a:t>
             </a:r>
             <a:r>
               <a:rPr sz="1300">
@@ -11990,7 +12045,7 @@
                 </a:solidFill>
                 <a:latin typeface="Segoe UI"/>
               </a:rPr>
-              <a:t>Hiển thị hoàn hảo trên Desktop (1920x1080), Laptop (1366x768), Tablet (768px) và Mobile (375px).</a:t>
+              <a:t>Hiển thị hoàn hảo trên Máy tính bàn (1920x1080), Laptop (1366x768), Máy tính bảng (768px) và Điện thoại (375px).</a:t>
             </a:r>
           </a:p>
           <a:p>
@@ -12046,7 +12101,7 @@
                 </a:solidFill>
                 <a:latin typeface="Segoe UI"/>
               </a:rPr>
-              <a:t>Chống SQL Injection, XSS trên form, bảo vệ LocalStorage, tự động logout khi hết hạn session.</a:t>
+              <a:t>Chống SQL Injection, XSS trên form, bảo vệ dữ liệu cục bộ, tự động đăng xuất khi hết phiên làm việc.</a:t>
             </a:r>
           </a:p>
           <a:p>
@@ -12074,7 +12129,7 @@
                 </a:solidFill>
                 <a:latin typeface="Segoe UI"/>
               </a:rPr>
-              <a:t>Thời gian tải trang ban đầu &lt; 1.5s, chuyển tab &lt; 100ms, bộ nhớ RAM tiêu thụ ổn định.</a:t>
+              <a:t>Thời gian tải trang ban đầu &lt; 1.5s, chuyển tab &lt; 100ms, tiêu thụ bộ nhớ RAM tối ưu.</a:t>
             </a:r>
           </a:p>
         </p:txBody>
@@ -12252,7 +12307,7 @@
           <a:lstStyle/>
           <a:p>
             <a:pPr>
-              <a:defRPr sz="2400" b="1">
+              <a:defRPr sz="2300" b="1">
                 <a:solidFill>
                   <a:srgbClr val="0F172A"/>
                 </a:solidFill>
@@ -12260,7 +12315,7 @@
               </a:defRPr>
             </a:pPr>
             <a:r>
-              <a:t>Framework Test Automation &amp; Thực Thi Tự Động</a:t>
+              <a:t>Khung Kiểm Thử Tự Động &amp; Thực Thi Trực Quan</a:t>
             </a:r>
           </a:p>
         </p:txBody>
@@ -12497,7 +12552,7 @@
                 </a:solidFill>
                 <a:latin typeface="Segoe UI"/>
               </a:rPr>
-              <a:t>• Clean Code: </a:t>
+              <a:t>• Thiết kế chuẩn mực: </a:t>
             </a:r>
             <a:r>
               <a:rPr sz="1250">
@@ -12805,7 +12860,7 @@
                 </a:solidFill>
                 <a:latin typeface="Segoe UI"/>
               </a:rPr>
-              <a:t>Chạy trọn gói cả 3 cấp độ (240 Test Cases) chỉ với 1 click duy nhất.</a:t>
+              <a:t>Chạy trọn gói cả 3 cấp độ (240 Ca kiểm thử) chỉ với 1 click duy nhất.</a:t>
             </a:r>
           </a:p>
         </p:txBody>
@@ -12969,7 +13024,7 @@
               </a:defRPr>
             </a:pPr>
             <a:r>
-              <a:t>Live Automation Demonstration</a:t>
+              <a:t>Trình diễn trực tiếp trên Trình duyệt</a:t>
             </a:r>
           </a:p>
         </p:txBody>
@@ -13048,7 +13103,7 @@
                 </a:solidFill>
                 <a:latin typeface="Segoe UI"/>
               </a:rPr>
-              <a:t>Thấy rõ chuột click, tự động gõ văn bản vào form, chuyển trang và hiện popup.</a:t>
+              <a:t>Thấy rõ chuột click, tự động điền form, chuyển trang và mở popup.</a:t>
             </a:r>
           </a:p>
           <a:p>
@@ -13076,7 +13131,7 @@
                 </a:solidFill>
                 <a:latin typeface="Segoe UI"/>
               </a:rPr>
-              <a:t>TestNG Report xuất báo cáo thời gian thực, chụp màn hình khi có lỗi.</a:t>
+              <a:t>TestNG Report xuất báo cáo thời gian thực, chụp màn hình tự động.</a:t>
             </a:r>
           </a:p>
           <a:p>
@@ -13104,7 +13159,7 @@
                 </a:solidFill>
                 <a:latin typeface="Segoe UI"/>
               </a:rPr>
-              <a:t>Assert kiểm tra chính xác từng element và chuỗi phản hồi.</a:t>
+              <a:t>Khẳng định (Assert) kiểm tra chính xác từng phần tử và kết quả.</a:t>
             </a:r>
           </a:p>
         </p:txBody>

</xml_diff>

<commit_message>
fix(slides): update official topic title to 'Kiểm thử website quản lý cửa hàng dịch vụ thú cưng'
</commit_message>
<xml_diff>
--- a/BaoCao/Slide_BaoCao_DeTai4_Nhom9.pptx
+++ b/BaoCao/Slide_BaoCao_DeTai4_Nhom9.pptx
@@ -3205,8 +3205,8 @@
         </p:nvSpPr>
         <p:spPr>
           <a:xfrm>
-            <a:off x="731520" y="1143000"/>
-            <a:ext cx="10728655" cy="2194560"/>
+            <a:off x="731520" y="1188720"/>
+            <a:ext cx="10728655" cy="2148840"/>
           </a:xfrm>
           <a:prstGeom prst="rect">
             <a:avLst/>
@@ -3250,7 +3250,7 @@
               </a:defRPr>
             </a:pPr>
             <a:r>
-              <a:t>ĐỀ TÀI 4: XÂY DỰNG VÀ KIỂM THỬ HỆ THỐNG QUẢN LÝ</a:t>
+              <a:t>ĐỀ TÀI 4: KIỂM THỬ WEBSITE QUẢN LÝ CỬA HÀNG</a:t>
             </a:r>
             <a:br/>
             <a:r>
@@ -3267,7 +3267,7 @@
               </a:defRPr>
             </a:pPr>
             <a:r>
-              <a:t>Giải pháp Quản lý Cửa hàng &amp; Dịch vụ Toàn diện • 240 Ca kiểm thử (Đơn vị - Tích hợp - Hệ thống Tự động hóa)</a:t>
+              <a:t>Giải pháp Đảm bảo Chất lượng Phần mềm Toàn diện • 240 Ca kiểm thử (Đơn vị - Tích hợp - Hệ thống Tự động hóa)</a:t>
             </a:r>
           </a:p>
         </p:txBody>
@@ -4951,7 +4951,7 @@
               </a:defRPr>
             </a:pPr>
             <a:r>
-              <a:t>Hệ thống đáp ứng trọn vẹn mọi yêu cầu chất lượng</a:t>
+              <a:t>Website Quản lý Cửa hàng Dịch vụ Thú cưng đáp ứng trọn vẹn mọi tiêu chuẩn chất lượng</a:t>
             </a:r>
           </a:p>
         </p:txBody>
@@ -5452,7 +5452,7 @@
               </a:defRPr>
             </a:pPr>
             <a:r>
-              <a:t>Hệ Thống Quản Lý Dịch Vụ Chăm Sóc Thú Cưng</a:t>
+              <a:t>Website Quản Lý Cửa Hàng Dịch Vụ Thú Cưng</a:t>
             </a:r>
           </a:p>
         </p:txBody>
@@ -6636,7 +6636,7 @@
               </a:defRPr>
             </a:pPr>
             <a:r>
-              <a:t>🎯 MỤC TIÊU CHẤT LƯỢNG HỆ THỐNG</a:t>
+              <a:t>🎯 MỤC TIÊU CHẤT LƯỢNG WEBSITE</a:t>
             </a:r>
           </a:p>
           <a:p>
@@ -7431,7 +7431,7 @@
                 </a:solidFill>
                 <a:latin typeface="Segoe UI"/>
               </a:rPr>
-              <a:t>Nghiên cứu yêu cầu nghiệp vụ hệ thống quản lý thú cưng.</a:t>
+              <a:t>Nghiên cứu yêu cầu nghiệp vụ website quản lý dịch vụ thú cưng.</a:t>
             </a:r>
           </a:p>
           <a:p>

</xml_diff>

<commit_message>
fix(all): synchronize exact topic title 'Kiểm thử website quản lý cửa hàng dịch vụ thú cưng' across Word, PDF and Slide deck
</commit_message>
<xml_diff>
--- a/BaoCao/Slide_BaoCao_DeTai4_Nhom9.pptx
+++ b/BaoCao/Slide_BaoCao_DeTai4_Nhom9.pptx
@@ -3254,7 +3254,7 @@
             </a:r>
             <a:br/>
             <a:r>
-              <a:t>DỊCH VỤ CHĂM SÓC THÚ CƯNG</a:t>
+              <a:t>DỊCH VỤ THÚ CƯNG</a:t>
             </a:r>
           </a:p>
           <a:p>
@@ -3612,7 +3612,7 @@
               </a:defRPr>
             </a:pPr>
             <a:r>
-              <a:t>Giảng viên hướng dẫn: ThS. Hoàng Thị Phương Lan • Nhóm 9 • Lớp tín chỉ: Kiểm thử phần mềm-1-1-26(N04) • Hà Nội 2026</a:t>
+              <a:t>Giảng viên hướng dẫn: Lê Tuấn Anh • Nhóm 9 • Lớp tín chỉ: Kiểm thử phần mềm-1-1-26(N04) • Bắc Ninh 2026</a:t>
             </a:r>
           </a:p>
         </p:txBody>

</xml_diff>